<commit_message>
Audit manuscript equations, method evidence, narrative and figure content
</commit_message>
<xml_diff>
--- a/artifacts/active/Figure2_organization_rsi_adapted_grouped.pptx
+++ b/artifacts/active/Figure2_organization_rsi_adapted_grouped.pptx
@@ -5721,7 +5721,7 @@
                   <a:ea typeface="Cambria"/>
                   <a:cs typeface="Cambria"/>
                 </a:rPr>
-                <a:t>§ 8    Open Problems and</a:t>
+                <a:t>§ 8    Open Problems</a:t>
               </a:r>
               <a:endParaRPr sz="2610"/>
             </a:p>
@@ -5738,7 +5738,7 @@
                   <a:ea typeface="Cambria"/>
                   <a:cs typeface="Cambria"/>
                 </a:rPr>
-                <a:t>Case Studies</a:t>
+                <a:t>and System Analyses</a:t>
               </a:r>
               <a:endParaRPr sz="2610"/>
             </a:p>
@@ -5840,7 +5840,7 @@
                   <a:ea typeface="Cambria"/>
                   <a:cs typeface="Cambria"/>
                 </a:rPr>
-                <a:t>System definition</a:t>
+                <a:t>Motivation and scope</a:t>
               </a:r>
               <a:endParaRPr sz="2370"/>
             </a:p>
@@ -5908,7 +5908,7 @@
                   <a:ea typeface="Cambria"/>
                   <a:cs typeface="Cambria"/>
                 </a:rPr>
-                <a:t>Review scope</a:t>
+                <a:t>Agent interaction loop</a:t>
               </a:r>
               <a:endParaRPr sz="2370"/>
             </a:p>
@@ -5925,7 +5925,7 @@
                   <a:ea typeface="Cambria"/>
                   <a:cs typeface="Cambria"/>
                 </a:rPr>
-                <a:t>Paper-card evidence</a:t>
+                <a:t>Tasks and module reuse</a:t>
               </a:r>
               <a:endParaRPr sz="2370"/>
             </a:p>
@@ -5976,7 +5976,7 @@
                   <a:ea typeface="Cambria"/>
                   <a:cs typeface="Cambria"/>
                 </a:rPr>
-                <a:t>Temporal representation</a:t>
+                <a:t>Model interfaces</a:t>
               </a:r>
               <a:endParaRPr sz="2180"/>
             </a:p>
@@ -5993,7 +5993,7 @@
                   <a:ea typeface="Cambria"/>
                   <a:cs typeface="Cambria"/>
                 </a:rPr>
-                <a:t>Alignment and reasoning</a:t>
+                <a:t>Temporal adaptation</a:t>
               </a:r>
               <a:endParaRPr sz="2180"/>
             </a:p>
@@ -6010,7 +6010,7 @@
                   <a:ea typeface="Cambria"/>
                   <a:cs typeface="Cambria"/>
                 </a:rPr>
-                <a:t>LLM-side methods</a:t>
+                <a:t>Workflow policies</a:t>
               </a:r>
               <a:endParaRPr sz="2180"/>
             </a:p>
@@ -6061,7 +6061,7 @@
                   <a:ea typeface="Cambria"/>
                   <a:cs typeface="Cambria"/>
                 </a:rPr>
-                <a:t>Tools and memory          Control and execution</a:t>
+                <a:t>Interfaces, tools, memory</a:t>
               </a:r>
               <a:endParaRPr sz="2160"/>
             </a:p>
@@ -6078,7 +6078,7 @@
                   <a:ea typeface="Cambria"/>
                   <a:cs typeface="Cambria"/>
                 </a:rPr>
-                <a:t>Temporal state             Provenance and validation</a:t>
+                <a:t>Control, plans, learning, roles</a:t>
               </a:r>
               <a:endParaRPr sz="2160"/>
             </a:p>
@@ -6129,7 +6129,7 @@
                   <a:ea typeface="Cambria"/>
                   <a:cs typeface="Cambria"/>
                 </a:rPr>
-                <a:t>Time-series harnesses     Reusable modules</a:t>
+                <a:t>Data management         Temporal processing</a:t>
               </a:r>
               <a:endParaRPr sz="2000"/>
             </a:p>
@@ -6146,7 +6146,7 @@
                   <a:ea typeface="Cambria"/>
                   <a:cs typeface="Cambria"/>
                 </a:rPr>
-                <a:t>Task contracts             Benchmark protocols</a:t>
+                <a:t>Context and memory      Temporal validation</a:t>
               </a:r>
               <a:endParaRPr sz="2000"/>
             </a:p>
@@ -6282,7 +6282,7 @@
                   <a:ea typeface="Cambria"/>
                   <a:cs typeface="Cambria"/>
                 </a:rPr>
-                <a:t>Traces and episodes        Reproducible evaluation</a:t>
+                <a:t>Traces and episodes      Evaluation</a:t>
               </a:r>
               <a:endParaRPr sz="1870"/>
             </a:p>
@@ -6333,7 +6333,7 @@
                   <a:ea typeface="Cambria"/>
                   <a:cs typeface="Cambria"/>
                 </a:rPr>
-                <a:t>Paper-card database        Module-level counts</a:t>
+                <a:t>Transfer and memory      Evidence quality</a:t>
               </a:r>
               <a:endParaRPr sz="1850"/>
             </a:p>
@@ -6350,7 +6350,7 @@
                   <a:ea typeface="Cambria"/>
                   <a:cs typeface="Cambria"/>
                 </a:rPr>
-                <a:t>Open tasks                 Evidence gaps</a:t>
+                <a:t>Decision feedback        Design implications</a:t>
               </a:r>
               <a:endParaRPr sz="1850"/>
             </a:p>
@@ -6401,7 +6401,7 @@
                   <a:ea typeface="Cambria"/>
                   <a:cs typeface="Cambria"/>
                 </a:rPr>
-                <a:t>System map</a:t>
+                <a:t>Construction choices</a:t>
               </a:r>
               <a:endParaRPr sz="2370"/>
             </a:p>
@@ -6418,7 +6418,7 @@
                   <a:ea typeface="Cambria"/>
                   <a:cs typeface="Cambria"/>
                 </a:rPr>
-                <a:t>Open problems</a:t>
+                <a:t>Evaluation and reuse</a:t>
               </a:r>
               <a:endParaRPr sz="2370"/>
             </a:p>
@@ -6725,7 +6725,7 @@
                   <a:ea typeface="Cambria"/>
                   <a:cs typeface="Cambria"/>
                 </a:rPr>
-                <a:t>Paper cards record module-level contributions across the LLM, Harness, temporal, task, and evaluation layers.</a:t>
+                <a:t>LLM capabilities combine with three Harness scopes to support temporal tasks.</a:t>
               </a:r>
             </a:p>
           </p:txBody>
@@ -6894,7 +6894,7 @@
                   <a:ea typeface="Cambria"/>
                   <a:cs typeface="Cambria"/>
                 </a:rPr>
-                <a:t>Language capability</a:t>
+                <a:t>LLM interaction</a:t>
               </a:r>
             </a:p>
           </p:txBody>
@@ -6961,7 +6961,7 @@
                   <a:ea typeface="Cambria"/>
                   <a:cs typeface="Cambria"/>
                 </a:rPr>
-                <a:t>representation</a:t>
+                <a:t>interpret observations</a:t>
               </a:r>
             </a:p>
             <a:p xmlns:a="http://schemas.openxmlformats.org/drawingml/2006/main">
@@ -6984,7 +6984,7 @@
                   <a:ea typeface="Cambria"/>
                   <a:cs typeface="Cambria"/>
                 </a:rPr>
-                <a:t>alignment</a:t>
+                <a:t>select tool actions</a:t>
               </a:r>
             </a:p>
             <a:p xmlns:a="http://schemas.openxmlformats.org/drawingml/2006/main">
@@ -7007,7 +7007,7 @@
                   <a:ea typeface="Cambria"/>
                   <a:cs typeface="Cambria"/>
                 </a:rPr>
-                <a:t>temporal reasoning</a:t>
+                <a:t>use returned feedback</a:t>
               </a:r>
             </a:p>
             <a:p xmlns:a="http://schemas.openxmlformats.org/drawingml/2006/main">
@@ -7030,7 +7030,7 @@
                   <a:ea typeface="Cambria"/>
                   <a:cs typeface="Cambria"/>
                 </a:rPr>
-                <a:t>ChatTS lineage</a:t>
+                <a:t>temporal adaptation</a:t>
               </a:r>
             </a:p>
           </p:txBody>
@@ -7132,7 +7132,7 @@
                   <a:ea typeface="Cambria"/>
                   <a:cs typeface="Cambria"/>
                 </a:rPr>
-                <a:t>LLM component</a:t>
+                <a:t>Action-selection model</a:t>
               </a:r>
             </a:p>
           </p:txBody>
@@ -7199,7 +7199,7 @@
                   <a:ea typeface="Cambria"/>
                   <a:cs typeface="Cambria"/>
                 </a:rPr>
-                <a:t>Paper card fields</a:t>
+                <a:t>Model contribution</a:t>
               </a:r>
             </a:p>
             <a:p xmlns:a="http://schemas.openxmlformats.org/drawingml/2006/main">
@@ -7222,7 +7222,7 @@
                   <a:ea typeface="Cambria"/>
                   <a:cs typeface="Cambria"/>
                 </a:rPr>
-                <a:t>claim · evidence · BibTeX</a:t>
+                <a:t>interfaces and training</a:t>
               </a:r>
             </a:p>
           </p:txBody>
@@ -7932,7 +7932,7 @@
                   <a:ea typeface="Cambria"/>
                   <a:cs typeface="Cambria"/>
                 </a:rPr>
-                <a:t>Evaluation and ledger</a:t>
+                <a:t>Evaluation and evidence</a:t>
               </a:r>
             </a:p>
           </p:txBody>

</xml_diff>